<commit_message>
Add team names and roll numbers to the report and presentation title pages
Co-Authored-By: Claude Opus 5.5 <noreply@anthropic.com>
</commit_message>
<xml_diff>
--- a/presentation/DeepOCR_Presentation.pptx
+++ b/presentation/DeepOCR_Presentation.pptx
@@ -121,45 +121,45 @@
   <p:extLst>
     <p:ext uri="{521415D9-36F7-43E2-AB2F-B90AF26B5E84}">
       <p14:sectionLst xmlns:p14="http://schemas.microsoft.com/office/powerpoint/2010/main">
-        <p14:section name="Introduction" id="{31F2CF65-7668-18BE-F6DA-AAB9B76C976B}">
+        <p14:section name="Introduction" id="{43C3FE7A-8476-908B-DBDC-C801BF46E273}">
           <p14:sldIdLst>
             <p14:sldId id="256"/>
             <p14:sldId id="257"/>
             <p14:sldId id="258"/>
           </p14:sldIdLst>
         </p14:section>
-        <p14:section name="System" id="{49BA8AD3-D3B7-C0D0-EFA9-59A775DF463D}">
+        <p14:section name="System" id="{22A415F9-0ECC-E66F-7439-6D88EEE9DCEB}">
           <p14:sldIdLst>
             <p14:sldId id="259"/>
             <p14:sldId id="260"/>
             <p14:sldId id="261"/>
           </p14:sldIdLst>
         </p14:section>
-        <p14:section name="Models" id="{9E6DC98F-9AFB-4EAC-D6D7-16A635C09E6A}">
+        <p14:section name="Models" id="{48429EB5-2144-133D-6672-1E728BB6976C}">
           <p14:sldIdLst>
             <p14:sldId id="262"/>
             <p14:sldId id="263"/>
           </p14:sldIdLst>
         </p14:section>
-        <p14:section name="Consensus" id="{F2B7AC40-F022-51D5-0053-3CFDA3ADA7EA}">
+        <p14:section name="Consensus" id="{C20BB2FE-7887-093B-6425-ECB390364ABC}">
           <p14:sldIdLst>
             <p14:sldId id="264"/>
           </p14:sldIdLst>
         </p14:section>
-        <p14:section name="Results" id="{B437ACE6-1857-311B-D223-701DE920E26D}">
+        <p14:section name="Results" id="{E18267C3-E1B5-1DA5-CD54-11F5CD59CC82}">
           <p14:sldIdLst>
             <p14:sldId id="265"/>
             <p14:sldId id="266"/>
             <p14:sldId id="267"/>
           </p14:sldIdLst>
         </p14:section>
-        <p14:section name="Application" id="{2B42C9CE-3FD7-E59B-69D8-5DF4F9043702}">
+        <p14:section name="Application" id="{981D3532-7D76-7A2D-F784-9FF3646DADEC}">
           <p14:sldIdLst>
             <p14:sldId id="268"/>
             <p14:sldId id="269"/>
           </p14:sldIdLst>
         </p14:section>
-        <p14:section name="Conclusion" id="{F1FDA12C-739F-E878-1376-FF845EF4EF48}">
+        <p14:section name="Conclusion" id="{B9299050-C382-6D94-EBC6-87DD3B6D269F}">
           <p14:sldIdLst>
             <p14:sldId id="270"/>
           </p14:sldIdLst>
@@ -341,7 +341,7 @@
           <c:smooth val="0"/>
           <c:extLst>
             <c:ext xmlns:c16="http://schemas.microsoft.com/office/drawing/2014/chart" uri="{C3380CC4-5D6E-409C-BE32-E72D297353CC}">
-              <c16:uniqueId val="{00000000-66CF-4F4D-86B2-8F31959E7918}"/>
+              <c16:uniqueId val="{00000000-6E2A-4C34-8E9D-F5BFC4A0894B}"/>
             </c:ext>
           </c:extLst>
         </c:ser>
@@ -466,7 +466,7 @@
           <c:smooth val="0"/>
           <c:extLst>
             <c:ext xmlns:c16="http://schemas.microsoft.com/office/drawing/2014/chart" uri="{C3380CC4-5D6E-409C-BE32-E72D297353CC}">
-              <c16:uniqueId val="{00000001-66CF-4F4D-86B2-8F31959E7918}"/>
+              <c16:uniqueId val="{00000001-6E2A-4C34-8E9D-F5BFC4A0894B}"/>
             </c:ext>
           </c:extLst>
         </c:ser>
@@ -779,7 +779,7 @@
           <c:smooth val="0"/>
           <c:extLst>
             <c:ext xmlns:c16="http://schemas.microsoft.com/office/drawing/2014/chart" uri="{C3380CC4-5D6E-409C-BE32-E72D297353CC}">
-              <c16:uniqueId val="{00000000-C466-47CD-8626-BBBF236E25AC}"/>
+              <c16:uniqueId val="{00000000-2ED9-40C0-AD72-B60A6B46A212}"/>
             </c:ext>
           </c:extLst>
         </c:ser>
@@ -874,7 +874,7 @@
           <c:smooth val="0"/>
           <c:extLst>
             <c:ext xmlns:c16="http://schemas.microsoft.com/office/drawing/2014/chart" uri="{C3380CC4-5D6E-409C-BE32-E72D297353CC}">
-              <c16:uniqueId val="{00000001-C466-47CD-8626-BBBF236E25AC}"/>
+              <c16:uniqueId val="{00000001-2ED9-40C0-AD72-B60A6B46A212}"/>
             </c:ext>
           </c:extLst>
         </c:ser>
@@ -1182,7 +1182,7 @@
           </c:val>
           <c:extLst>
             <c:ext xmlns:c16="http://schemas.microsoft.com/office/drawing/2014/chart" uri="{C3380CC4-5D6E-409C-BE32-E72D297353CC}">
-              <c16:uniqueId val="{00000000-CDEA-4A1C-8E85-3B900368524F}"/>
+              <c16:uniqueId val="{00000000-9A0F-4D56-B2C6-FA99A6C2AC44}"/>
             </c:ext>
           </c:extLst>
         </c:ser>
@@ -1299,7 +1299,7 @@
           </c:val>
           <c:extLst>
             <c:ext xmlns:c16="http://schemas.microsoft.com/office/drawing/2014/chart" uri="{C3380CC4-5D6E-409C-BE32-E72D297353CC}">
-              <c16:uniqueId val="{00000001-CDEA-4A1C-8E85-3B900368524F}"/>
+              <c16:uniqueId val="{00000001-9A0F-4D56-B2C6-FA99A6C2AC44}"/>
             </c:ext>
           </c:extLst>
         </c:ser>
@@ -1530,7 +1530,7 @@
           </c:val>
           <c:extLst>
             <c:ext xmlns:c16="http://schemas.microsoft.com/office/drawing/2014/chart" uri="{C3380CC4-5D6E-409C-BE32-E72D297353CC}">
-              <c16:uniqueId val="{00000000-127C-4396-B058-4288A00F917D}"/>
+              <c16:uniqueId val="{00000000-101C-4281-933B-FC49E12B8EDF}"/>
             </c:ext>
           </c:extLst>
         </c:ser>
@@ -1635,7 +1635,7 @@
           </c:val>
           <c:extLst>
             <c:ext xmlns:c16="http://schemas.microsoft.com/office/drawing/2014/chart" uri="{C3380CC4-5D6E-409C-BE32-E72D297353CC}">
-              <c16:uniqueId val="{00000001-127C-4396-B058-4288A00F917D}"/>
+              <c16:uniqueId val="{00000001-101C-4281-933B-FC49E12B8EDF}"/>
             </c:ext>
           </c:extLst>
         </c:ser>
@@ -1740,7 +1740,7 @@
           </c:val>
           <c:extLst>
             <c:ext xmlns:c16="http://schemas.microsoft.com/office/drawing/2014/chart" uri="{C3380CC4-5D6E-409C-BE32-E72D297353CC}">
-              <c16:uniqueId val="{00000002-127C-4396-B058-4288A00F917D}"/>
+              <c16:uniqueId val="{00000002-101C-4281-933B-FC49E12B8EDF}"/>
             </c:ext>
           </c:extLst>
         </c:ser>
@@ -1983,7 +1983,7 @@
           <c:smooth val="0"/>
           <c:extLst>
             <c:ext xmlns:c16="http://schemas.microsoft.com/office/drawing/2014/chart" uri="{C3380CC4-5D6E-409C-BE32-E72D297353CC}">
-              <c16:uniqueId val="{00000000-87D3-4EF5-9155-FBBAA1A68D15}"/>
+              <c16:uniqueId val="{00000000-AA44-4F92-8225-836CE0418E9F}"/>
             </c:ext>
           </c:extLst>
         </c:ser>
@@ -2072,7 +2072,7 @@
           <c:smooth val="0"/>
           <c:extLst>
             <c:ext xmlns:c16="http://schemas.microsoft.com/office/drawing/2014/chart" uri="{C3380CC4-5D6E-409C-BE32-E72D297353CC}">
-              <c16:uniqueId val="{00000001-87D3-4EF5-9155-FBBAA1A68D15}"/>
+              <c16:uniqueId val="{00000001-AA44-4F92-8225-836CE0418E9F}"/>
             </c:ext>
           </c:extLst>
         </c:ser>
@@ -2161,7 +2161,7 @@
           <c:smooth val="0"/>
           <c:extLst>
             <c:ext xmlns:c16="http://schemas.microsoft.com/office/drawing/2014/chart" uri="{C3380CC4-5D6E-409C-BE32-E72D297353CC}">
-              <c16:uniqueId val="{00000002-87D3-4EF5-9155-FBBAA1A68D15}"/>
+              <c16:uniqueId val="{00000002-AA44-4F92-8225-836CE0418E9F}"/>
             </c:ext>
           </c:extLst>
         </c:ser>
@@ -2250,7 +2250,7 @@
           <c:smooth val="0"/>
           <c:extLst>
             <c:ext xmlns:c16="http://schemas.microsoft.com/office/drawing/2014/chart" uri="{C3380CC4-5D6E-409C-BE32-E72D297353CC}">
-              <c16:uniqueId val="{00000003-87D3-4EF5-9155-FBBAA1A68D15}"/>
+              <c16:uniqueId val="{00000003-AA44-4F92-8225-836CE0418E9F}"/>
             </c:ext>
           </c:extLst>
         </c:ser>
@@ -2339,7 +2339,7 @@
           <c:smooth val="0"/>
           <c:extLst>
             <c:ext xmlns:c16="http://schemas.microsoft.com/office/drawing/2014/chart" uri="{C3380CC4-5D6E-409C-BE32-E72D297353CC}">
-              <c16:uniqueId val="{00000004-87D3-4EF5-9155-FBBAA1A68D15}"/>
+              <c16:uniqueId val="{00000004-AA44-4F92-8225-836CE0418E9F}"/>
             </c:ext>
           </c:extLst>
         </c:ser>
@@ -2517,7 +2517,7 @@
     </p:spTree>
     <p:extLst>
       <p:ext uri="{BB962C8B-B14F-4D97-AF65-F5344CB8AC3E}">
-        <p14:creationId xmlns:p14="http://schemas.microsoft.com/office/powerpoint/2010/main" val="2068937493"/>
+        <p14:creationId xmlns:p14="http://schemas.microsoft.com/office/powerpoint/2010/main" val="3741121361"/>
       </p:ext>
     </p:extLst>
   </p:cSld>
@@ -4782,7 +4782,7 @@
         <p:spPr>
           <a:xfrm>
             <a:off x="640080" y="1325880"/>
-            <a:ext cx="6400800" cy="365760"/>
+            <a:ext cx="6583680" cy="365760"/>
           </a:xfrm>
           <a:prstGeom prst="rect">
             <a:avLst/>
@@ -4803,7 +4803,7 @@
                   <a:srgbClr val="C7D2FE"/>
                 </a:solidFill>
               </a:rPr>
-              <a:t>PROJECT PRESENTATION</a:t>
+              <a:t>PROJECT PRESENTATION  ·  OCTOBER 2026</a:t>
             </a:r>
             <a:endParaRPr lang="en-US" sz="1400" dirty="0"/>
           </a:p>
@@ -4857,8 +4857,8 @@
         </p:nvSpPr>
         <p:spPr>
           <a:xfrm>
-            <a:off x="640080" y="3154680"/>
-            <a:ext cx="6583680" cy="1143000"/>
+            <a:off x="640080" y="3063240"/>
+            <a:ext cx="6583680" cy="914400"/>
           </a:xfrm>
           <a:prstGeom prst="rect">
             <a:avLst/>
@@ -4887,32 +4887,39 @@
       </p:sp>
       <p:sp>
         <p:nvSpPr>
-          <p:cNvPr id="9" name="Shape 7"/>
-          <p:cNvSpPr/>
-          <p:nvPr/>
-        </p:nvSpPr>
-        <p:spPr>
-          <a:xfrm>
-            <a:off x="640080" y="4663440"/>
-            <a:ext cx="1965960" cy="457200"/>
-          </a:xfrm>
-          <a:prstGeom prst="roundRect">
-            <a:avLst>
-              <a:gd name="adj" fmla="val 50000"/>
-            </a:avLst>
-          </a:prstGeom>
-          <a:solidFill>
-            <a:schemeClr val="bg1">
-              <a:alpha val="12000"/>
-            </a:schemeClr>
-          </a:solidFill>
-          <a:ln w="9525">
-            <a:solidFill>
-              <a:srgbClr val="C7D2FE"/>
-            </a:solidFill>
-            <a:prstDash val="solid"/>
-          </a:ln>
-        </p:spPr>
+          <p:cNvPr id="9" name="Text 7"/>
+          <p:cNvSpPr txBox="1"/>
+          <p:nvPr/>
+        </p:nvSpPr>
+        <p:spPr>
+          <a:xfrm>
+            <a:off x="640080" y="4343400"/>
+            <a:ext cx="6583680" cy="274320"/>
+          </a:xfrm>
+          <a:prstGeom prst="rect">
+            <a:avLst/>
+          </a:prstGeom>
+          <a:noFill/>
+          <a:ln/>
+        </p:spPr>
+        <p:txBody>
+          <a:bodyPr wrap="square" lIns="0" tIns="0" rIns="0" bIns="0" rtlCol="0" anchor="t"/>
+          <a:lstStyle/>
+          <a:p>
+            <a:pPr marL="0" indent="0">
+              <a:buNone/>
+            </a:pPr>
+            <a:r>
+              <a:rPr lang="en-US" sz="1200" b="1" kern="0" spc="300" dirty="0">
+                <a:solidFill>
+                  <a:srgbClr val="C7D2FE"/>
+                </a:solidFill>
+              </a:rPr>
+              <a:t>PRESENTED BY</a:t>
+            </a:r>
+            <a:endParaRPr lang="en-US" sz="1200" dirty="0"/>
+          </a:p>
+        </p:txBody>
       </p:sp>
       <p:sp>
         <p:nvSpPr>
@@ -4922,62 +4929,69 @@
         </p:nvSpPr>
         <p:spPr>
           <a:xfrm>
-            <a:off x="640080" y="4663440"/>
-            <a:ext cx="1965960" cy="457200"/>
-          </a:xfrm>
-          <a:prstGeom prst="rect">
-            <a:avLst/>
-          </a:prstGeom>
-          <a:noFill/>
-          <a:ln/>
-        </p:spPr>
-        <p:txBody>
-          <a:bodyPr wrap="square" lIns="0" tIns="0" rIns="0" bIns="0" rtlCol="0" anchor="ctr"/>
-          <a:lstStyle/>
-          <a:p>
-            <a:pPr marL="0" indent="0" algn="ctr">
-              <a:buNone/>
-            </a:pPr>
-            <a:r>
-              <a:rPr lang="en-US" sz="1300" dirty="0">
+            <a:off x="640080" y="4754880"/>
+            <a:ext cx="3200400" cy="329184"/>
+          </a:xfrm>
+          <a:prstGeom prst="rect">
+            <a:avLst/>
+          </a:prstGeom>
+          <a:noFill/>
+          <a:ln/>
+        </p:spPr>
+        <p:txBody>
+          <a:bodyPr wrap="square" lIns="0" tIns="0" rIns="0" bIns="0" rtlCol="0" anchor="t"/>
+          <a:lstStyle/>
+          <a:p>
+            <a:pPr marL="0" indent="0">
+              <a:buNone/>
+            </a:pPr>
+            <a:r>
+              <a:rPr lang="en-US" sz="1600" b="1" dirty="0">
                 <a:solidFill>
                   <a:schemeClr val="bg1"/>
                 </a:solidFill>
               </a:rPr>
-              <a:t>5 recognition models</a:t>
-            </a:r>
-            <a:endParaRPr lang="en-US" sz="1300" dirty="0"/>
-          </a:p>
-        </p:txBody>
-      </p:sp>
-      <p:sp>
-        <p:nvSpPr>
-          <p:cNvPr id="11" name="Shape 9"/>
-          <p:cNvSpPr/>
-          <p:nvPr/>
-        </p:nvSpPr>
-        <p:spPr>
-          <a:xfrm>
-            <a:off x="2788920" y="4663440"/>
-            <a:ext cx="1965960" cy="457200"/>
-          </a:xfrm>
-          <a:prstGeom prst="roundRect">
-            <a:avLst>
-              <a:gd name="adj" fmla="val 50000"/>
-            </a:avLst>
-          </a:prstGeom>
-          <a:solidFill>
-            <a:schemeClr val="bg1">
-              <a:alpha val="12000"/>
-            </a:schemeClr>
-          </a:solidFill>
-          <a:ln w="9525">
-            <a:solidFill>
-              <a:srgbClr val="C7D2FE"/>
-            </a:solidFill>
-            <a:prstDash val="solid"/>
-          </a:ln>
-        </p:spPr>
+              <a:t>Nalin Sharma</a:t>
+            </a:r>
+            <a:endParaRPr lang="en-US" sz="1600" dirty="0"/>
+          </a:p>
+        </p:txBody>
+      </p:sp>
+      <p:sp>
+        <p:nvSpPr>
+          <p:cNvPr id="11" name="Text 9"/>
+          <p:cNvSpPr txBox="1"/>
+          <p:nvPr/>
+        </p:nvSpPr>
+        <p:spPr>
+          <a:xfrm>
+            <a:off x="640080" y="5084064"/>
+            <a:ext cx="3200400" cy="274320"/>
+          </a:xfrm>
+          <a:prstGeom prst="rect">
+            <a:avLst/>
+          </a:prstGeom>
+          <a:noFill/>
+          <a:ln/>
+        </p:spPr>
+        <p:txBody>
+          <a:bodyPr wrap="square" lIns="0" tIns="0" rIns="0" bIns="0" rtlCol="0" anchor="t"/>
+          <a:lstStyle/>
+          <a:p>
+            <a:pPr marL="0" indent="0">
+              <a:buNone/>
+            </a:pPr>
+            <a:r>
+              <a:rPr lang="en-US" sz="1200" dirty="0">
+                <a:solidFill>
+                  <a:srgbClr val="C7D2FE"/>
+                </a:solidFill>
+              </a:rPr>
+              <a:t>CSJMA23001390292</a:t>
+            </a:r>
+            <a:endParaRPr lang="en-US" sz="1200" dirty="0"/>
+          </a:p>
+        </p:txBody>
       </p:sp>
       <p:sp>
         <p:nvSpPr>
@@ -4987,62 +5001,69 @@
         </p:nvSpPr>
         <p:spPr>
           <a:xfrm>
-            <a:off x="2788920" y="4663440"/>
-            <a:ext cx="1965960" cy="457200"/>
-          </a:xfrm>
-          <a:prstGeom prst="rect">
-            <a:avLst/>
-          </a:prstGeom>
-          <a:noFill/>
-          <a:ln/>
-        </p:spPr>
-        <p:txBody>
-          <a:bodyPr wrap="square" lIns="0" tIns="0" rIns="0" bIns="0" rtlCol="0" anchor="ctr"/>
-          <a:lstStyle/>
-          <a:p>
-            <a:pPr marL="0" indent="0" algn="ctr">
-              <a:buNone/>
-            </a:pPr>
-            <a:r>
-              <a:rPr lang="en-US" sz="1300" dirty="0">
+            <a:off x="4023360" y="4754880"/>
+            <a:ext cx="3200400" cy="329184"/>
+          </a:xfrm>
+          <a:prstGeom prst="rect">
+            <a:avLst/>
+          </a:prstGeom>
+          <a:noFill/>
+          <a:ln/>
+        </p:spPr>
+        <p:txBody>
+          <a:bodyPr wrap="square" lIns="0" tIns="0" rIns="0" bIns="0" rtlCol="0" anchor="t"/>
+          <a:lstStyle/>
+          <a:p>
+            <a:pPr marL="0" indent="0">
+              <a:buNone/>
+            </a:pPr>
+            <a:r>
+              <a:rPr lang="en-US" sz="1600" b="1" dirty="0">
                 <a:solidFill>
                   <a:schemeClr val="bg1"/>
                 </a:solidFill>
               </a:rPr>
-              <a:t>Consensus voting</a:t>
-            </a:r>
-            <a:endParaRPr lang="en-US" sz="1300" dirty="0"/>
-          </a:p>
-        </p:txBody>
-      </p:sp>
-      <p:sp>
-        <p:nvSpPr>
-          <p:cNvPr id="13" name="Shape 11"/>
-          <p:cNvSpPr/>
-          <p:nvPr/>
-        </p:nvSpPr>
-        <p:spPr>
-          <a:xfrm>
-            <a:off x="4937760" y="4663440"/>
-            <a:ext cx="1965960" cy="457200"/>
-          </a:xfrm>
-          <a:prstGeom prst="roundRect">
-            <a:avLst>
-              <a:gd name="adj" fmla="val 50000"/>
-            </a:avLst>
-          </a:prstGeom>
-          <a:solidFill>
-            <a:schemeClr val="bg1">
-              <a:alpha val="12000"/>
-            </a:schemeClr>
-          </a:solidFill>
-          <a:ln w="9525">
-            <a:solidFill>
-              <a:srgbClr val="C7D2FE"/>
-            </a:solidFill>
-            <a:prstDash val="solid"/>
-          </a:ln>
-        </p:spPr>
+              <a:t>Amritansh Singh Gaur</a:t>
+            </a:r>
+            <a:endParaRPr lang="en-US" sz="1600" dirty="0"/>
+          </a:p>
+        </p:txBody>
+      </p:sp>
+      <p:sp>
+        <p:nvSpPr>
+          <p:cNvPr id="13" name="Text 11"/>
+          <p:cNvSpPr txBox="1"/>
+          <p:nvPr/>
+        </p:nvSpPr>
+        <p:spPr>
+          <a:xfrm>
+            <a:off x="4023360" y="5084064"/>
+            <a:ext cx="3200400" cy="274320"/>
+          </a:xfrm>
+          <a:prstGeom prst="rect">
+            <a:avLst/>
+          </a:prstGeom>
+          <a:noFill/>
+          <a:ln/>
+        </p:spPr>
+        <p:txBody>
+          <a:bodyPr wrap="square" lIns="0" tIns="0" rIns="0" bIns="0" rtlCol="0" anchor="t"/>
+          <a:lstStyle/>
+          <a:p>
+            <a:pPr marL="0" indent="0">
+              <a:buNone/>
+            </a:pPr>
+            <a:r>
+              <a:rPr lang="en-US" sz="1200" dirty="0">
+                <a:solidFill>
+                  <a:srgbClr val="C7D2FE"/>
+                </a:solidFill>
+              </a:rPr>
+              <a:t>CSJMA23001390309</a:t>
+            </a:r>
+            <a:endParaRPr lang="en-US" sz="1200" dirty="0"/>
+          </a:p>
+        </p:txBody>
       </p:sp>
       <p:sp>
         <p:nvSpPr>
@@ -5052,31 +5073,31 @@
         </p:nvSpPr>
         <p:spPr>
           <a:xfrm>
-            <a:off x="4937760" y="4663440"/>
-            <a:ext cx="1965960" cy="457200"/>
-          </a:xfrm>
-          <a:prstGeom prst="rect">
-            <a:avLst/>
-          </a:prstGeom>
-          <a:noFill/>
-          <a:ln/>
-        </p:spPr>
-        <p:txBody>
-          <a:bodyPr wrap="square" lIns="0" tIns="0" rIns="0" bIns="0" rtlCol="0" anchor="ctr"/>
-          <a:lstStyle/>
-          <a:p>
-            <a:pPr marL="0" indent="0" algn="ctr">
-              <a:buNone/>
-            </a:pPr>
-            <a:r>
-              <a:rPr lang="en-US" sz="1300" dirty="0">
+            <a:off x="640080" y="5504688"/>
+            <a:ext cx="3200400" cy="329184"/>
+          </a:xfrm>
+          <a:prstGeom prst="rect">
+            <a:avLst/>
+          </a:prstGeom>
+          <a:noFill/>
+          <a:ln/>
+        </p:spPr>
+        <p:txBody>
+          <a:bodyPr wrap="square" lIns="0" tIns="0" rIns="0" bIns="0" rtlCol="0" anchor="t"/>
+          <a:lstStyle/>
+          <a:p>
+            <a:pPr marL="0" indent="0">
+              <a:buNone/>
+            </a:pPr>
+            <a:r>
+              <a:rPr lang="en-US" sz="1600" b="1" dirty="0">
                 <a:solidFill>
                   <a:schemeClr val="bg1"/>
                 </a:solidFill>
               </a:rPr>
-              <a:t>Review studio</a:t>
-            </a:r>
-            <a:endParaRPr lang="en-US" sz="1300" dirty="0"/>
+              <a:t>Vineet Kumar Singh</a:t>
+            </a:r>
+            <a:endParaRPr lang="en-US" sz="1600" dirty="0"/>
           </a:p>
         </p:txBody>
       </p:sp>
@@ -5088,8 +5109,8 @@
         </p:nvSpPr>
         <p:spPr>
           <a:xfrm>
-            <a:off x="640080" y="5897880"/>
-            <a:ext cx="3657600" cy="320040"/>
+            <a:off x="640080" y="5833872"/>
+            <a:ext cx="3200400" cy="274320"/>
           </a:xfrm>
           <a:prstGeom prst="rect">
             <a:avLst/>
@@ -5105,14 +5126,86 @@
               <a:buNone/>
             </a:pPr>
             <a:r>
-              <a:rPr lang="en-US" sz="1300" dirty="0">
+              <a:rPr lang="en-US" sz="1200" dirty="0">
                 <a:solidFill>
                   <a:srgbClr val="C7D2FE"/>
                 </a:solidFill>
               </a:rPr>
-              <a:t>October 2026</a:t>
-            </a:r>
-            <a:endParaRPr lang="en-US" sz="1300" dirty="0"/>
+              <a:t>CSJMA23001390311</a:t>
+            </a:r>
+            <a:endParaRPr lang="en-US" sz="1200" dirty="0"/>
+          </a:p>
+        </p:txBody>
+      </p:sp>
+      <p:sp>
+        <p:nvSpPr>
+          <p:cNvPr id="16" name="Text 14"/>
+          <p:cNvSpPr txBox="1"/>
+          <p:nvPr/>
+        </p:nvSpPr>
+        <p:spPr>
+          <a:xfrm>
+            <a:off x="4023360" y="5504688"/>
+            <a:ext cx="3200400" cy="329184"/>
+          </a:xfrm>
+          <a:prstGeom prst="rect">
+            <a:avLst/>
+          </a:prstGeom>
+          <a:noFill/>
+          <a:ln/>
+        </p:spPr>
+        <p:txBody>
+          <a:bodyPr wrap="square" lIns="0" tIns="0" rIns="0" bIns="0" rtlCol="0" anchor="t"/>
+          <a:lstStyle/>
+          <a:p>
+            <a:pPr marL="0" indent="0">
+              <a:buNone/>
+            </a:pPr>
+            <a:r>
+              <a:rPr lang="en-US" sz="1600" b="1" dirty="0">
+                <a:solidFill>
+                  <a:schemeClr val="bg1"/>
+                </a:solidFill>
+              </a:rPr>
+              <a:t>Rajyavardhan Radhey</a:t>
+            </a:r>
+            <a:endParaRPr lang="en-US" sz="1600" dirty="0"/>
+          </a:p>
+        </p:txBody>
+      </p:sp>
+      <p:sp>
+        <p:nvSpPr>
+          <p:cNvPr id="17" name="Text 15"/>
+          <p:cNvSpPr txBox="1"/>
+          <p:nvPr/>
+        </p:nvSpPr>
+        <p:spPr>
+          <a:xfrm>
+            <a:off x="4023360" y="5833872"/>
+            <a:ext cx="3200400" cy="274320"/>
+          </a:xfrm>
+          <a:prstGeom prst="rect">
+            <a:avLst/>
+          </a:prstGeom>
+          <a:noFill/>
+          <a:ln/>
+        </p:spPr>
+        <p:txBody>
+          <a:bodyPr wrap="square" lIns="0" tIns="0" rIns="0" bIns="0" rtlCol="0" anchor="t"/>
+          <a:lstStyle/>
+          <a:p>
+            <a:pPr marL="0" indent="0">
+              <a:buNone/>
+            </a:pPr>
+            <a:r>
+              <a:rPr lang="en-US" sz="1200" dirty="0">
+                <a:solidFill>
+                  <a:srgbClr val="C7D2FE"/>
+                </a:solidFill>
+              </a:rPr>
+              <a:t>CSJMA23001390322</a:t>
+            </a:r>
+            <a:endParaRPr lang="en-US" sz="1200" dirty="0"/>
           </a:p>
         </p:txBody>
       </p:sp>

</xml_diff>